<commit_message>
Vierter Termin: Referat oder Vortrag und Diskussion
- Termin 3 nur noch Besprechung Paket 2 und aktuelle Entwicklungen
- Paket 3: Fazit zum Gespräch und Referat planen
- Termin 4: Referat/Vortrag, Diskussion, Bewertungsgrundlagen; Paket 4: Ausarbeitung
- Agenda und Terminübersicht in allen Präsentationen auf vier Termine

Co-Authored-By: Claude Opus 5.5 <noreply@anthropic.com>
Claude-Session: https://claude.ai/code/session_01KjTLRV2ju5iuSRgoeZgmvB
</commit_message>
<xml_diff>
--- a/technikdidaktisches-kolloquium/praesentationen/TdK_Termin-1_Einfuehrung-Technikbegriff.pptx
+++ b/technikdidaktisches-kolloquium/praesentationen/TdK_Termin-1_Einfuehrung-Technikbegriff.pptx
@@ -2727,8 +2727,8 @@
         </p:nvSpPr>
         <p:spPr>
           <a:xfrm>
-            <a:off x="548640" y="3611880"/>
-            <a:ext cx="1828800" cy="566928"/>
+            <a:off x="548640" y="3566160"/>
+            <a:ext cx="1828800" cy="530352"/>
           </a:xfrm>
           <a:prstGeom prst="rect">
             <a:avLst/>
@@ -2765,8 +2765,8 @@
         </p:nvSpPr>
         <p:spPr>
           <a:xfrm>
-            <a:off x="2560320" y="3611880"/>
-            <a:ext cx="8961120" cy="566928"/>
+            <a:off x="2560320" y="3566160"/>
+            <a:ext cx="8961120" cy="530352"/>
           </a:xfrm>
           <a:prstGeom prst="rect">
             <a:avLst/>
@@ -2801,8 +2801,8 @@
         </p:nvSpPr>
         <p:spPr>
           <a:xfrm>
-            <a:off x="548640" y="4325112"/>
-            <a:ext cx="1828800" cy="566928"/>
+            <a:off x="548640" y="4206240"/>
+            <a:ext cx="1828800" cy="530352"/>
           </a:xfrm>
           <a:prstGeom prst="rect">
             <a:avLst/>
@@ -2839,8 +2839,8 @@
         </p:nvSpPr>
         <p:spPr>
           <a:xfrm>
-            <a:off x="2560320" y="4325112"/>
-            <a:ext cx="8961120" cy="566928"/>
+            <a:off x="2560320" y="4206240"/>
+            <a:ext cx="8961120" cy="530352"/>
           </a:xfrm>
           <a:prstGeom prst="rect">
             <a:avLst/>
@@ -2875,8 +2875,8 @@
         </p:nvSpPr>
         <p:spPr>
           <a:xfrm>
-            <a:off x="548640" y="5038344"/>
-            <a:ext cx="1828800" cy="566928"/>
+            <a:off x="548640" y="4846320"/>
+            <a:ext cx="1828800" cy="530352"/>
           </a:xfrm>
           <a:prstGeom prst="rect">
             <a:avLst/>
@@ -2913,8 +2913,8 @@
         </p:nvSpPr>
         <p:spPr>
           <a:xfrm>
-            <a:off x="2560320" y="5038344"/>
-            <a:ext cx="8961120" cy="566928"/>
+            <a:off x="2560320" y="4846320"/>
+            <a:ext cx="8961120" cy="530352"/>
           </a:xfrm>
           <a:prstGeom prst="rect">
             <a:avLst/>
@@ -2935,7 +2935,81 @@
                   <a:srgbClr val="C9D8E6"/>
                 </a:solidFill>
               </a:rPr>
-              <a:t>Besprechung Paket 2 · Aktuelle Entwicklungen · Referat und Diskussion</a:t>
+              <a:t>Besprechung Paket 2 · Aktuelle Entwicklungen im Technikunterricht</a:t>
+            </a:r>
+            <a:endParaRPr lang="en-US" sz="2200" dirty="0"/>
+          </a:p>
+        </p:txBody>
+      </p:sp>
+      <p:sp>
+        <p:nvSpPr>
+          <p:cNvPr id="10" name="box-9"/>
+          <p:cNvSpPr txBox="1"/>
+          <p:nvPr/>
+        </p:nvSpPr>
+        <p:spPr>
+          <a:xfrm>
+            <a:off x="548640" y="5486400"/>
+            <a:ext cx="1828800" cy="530352"/>
+          </a:xfrm>
+          <a:prstGeom prst="rect">
+            <a:avLst/>
+          </a:prstGeom>
+          <a:solidFill>
+            <a:srgbClr val="0F4F7E"/>
+          </a:solidFill>
+          <a:ln/>
+        </p:spPr>
+        <p:txBody>
+          <a:bodyPr wrap="square" lIns="101600" tIns="101600" rIns="101600" bIns="101600" rtlCol="0" anchor="ctr"/>
+          <a:lstStyle/>
+          <a:p>
+            <a:pPr algn="ctr" indent="0" marL="0">
+              <a:buNone/>
+            </a:pPr>
+            <a:r>
+              <a:rPr lang="en-US" sz="2000" b="1" dirty="0">
+                <a:solidFill>
+                  <a:srgbClr val="FFFFFF"/>
+                </a:solidFill>
+              </a:rPr>
+              <a:t>Termin 4</a:t>
+            </a:r>
+            <a:endParaRPr lang="en-US" sz="2000" dirty="0"/>
+          </a:p>
+        </p:txBody>
+      </p:sp>
+      <p:sp>
+        <p:nvSpPr>
+          <p:cNvPr id="11" name="text-10"/>
+          <p:cNvSpPr txBox="1"/>
+          <p:nvPr/>
+        </p:nvSpPr>
+        <p:spPr>
+          <a:xfrm>
+            <a:off x="2560320" y="5486400"/>
+            <a:ext cx="8961120" cy="530352"/>
+          </a:xfrm>
+          <a:prstGeom prst="rect">
+            <a:avLst/>
+          </a:prstGeom>
+          <a:noFill/>
+          <a:ln/>
+        </p:spPr>
+        <p:txBody>
+          <a:bodyPr wrap="square" lIns="38100" tIns="38100" rIns="38100" bIns="38100" rtlCol="0" anchor="ctr"/>
+          <a:lstStyle/>
+          <a:p>
+            <a:pPr algn="l" indent="0" marL="0">
+              <a:buNone/>
+            </a:pPr>
+            <a:r>
+              <a:rPr lang="en-US" sz="2200" dirty="0">
+                <a:solidFill>
+                  <a:srgbClr val="C9D8E6"/>
+                </a:solidFill>
+              </a:rPr>
+              <a:t>Referat oder Vortrag und Diskussion</a:t>
             </a:r>
             <a:endParaRPr lang="en-US" sz="2200" dirty="0"/>
           </a:p>
@@ -2968,7 +3042,7 @@
       </p:grpSpPr>
       <p:sp>
         <p:nvSpPr>
-          <p:cNvPr id="2" name="titel-55"/>
+          <p:cNvPr id="2" name="titel-59"/>
           <p:cNvSpPr txBox="1"/>
           <p:nvPr/>
         </p:nvSpPr>
@@ -3004,7 +3078,7 @@
       </p:sp>
       <p:sp>
         <p:nvSpPr>
-          <p:cNvPr id="3" name="box-56"/>
+          <p:cNvPr id="3" name="box-60"/>
           <p:cNvSpPr txBox="1"/>
           <p:nvPr/>
         </p:nvSpPr>
@@ -3056,7 +3130,7 @@
       </p:sp>
       <p:sp>
         <p:nvSpPr>
-          <p:cNvPr id="4" name="box-57"/>
+          <p:cNvPr id="4" name="box-61"/>
           <p:cNvSpPr txBox="1"/>
           <p:nvPr/>
         </p:nvSpPr>
@@ -3096,7 +3170,7 @@
       </p:sp>
       <p:sp>
         <p:nvSpPr>
-          <p:cNvPr id="5" name="box-58"/>
+          <p:cNvPr id="5" name="box-62"/>
           <p:cNvSpPr txBox="1"/>
           <p:nvPr/>
         </p:nvSpPr>
@@ -3136,7 +3210,7 @@
       </p:sp>
       <p:sp>
         <p:nvSpPr>
-          <p:cNvPr id="6" name="box-59"/>
+          <p:cNvPr id="6" name="box-63"/>
           <p:cNvSpPr txBox="1"/>
           <p:nvPr/>
         </p:nvSpPr>
@@ -3176,7 +3250,7 @@
       </p:sp>
       <p:sp>
         <p:nvSpPr>
-          <p:cNvPr id="7" name="box-60"/>
+          <p:cNvPr id="7" name="box-64"/>
           <p:cNvSpPr txBox="1"/>
           <p:nvPr/>
         </p:nvSpPr>
@@ -3216,7 +3290,7 @@
       </p:sp>
       <p:sp>
         <p:nvSpPr>
-          <p:cNvPr id="8" name="box-61"/>
+          <p:cNvPr id="8" name="box-65"/>
           <p:cNvSpPr txBox="1"/>
           <p:nvPr/>
         </p:nvSpPr>
@@ -3256,7 +3330,7 @@
       </p:sp>
       <p:sp>
         <p:nvSpPr>
-          <p:cNvPr id="9" name="box-62"/>
+          <p:cNvPr id="9" name="box-66"/>
           <p:cNvSpPr txBox="1"/>
           <p:nvPr/>
         </p:nvSpPr>
@@ -3296,7 +3370,7 @@
       </p:sp>
       <p:sp>
         <p:nvSpPr>
-          <p:cNvPr id="10" name="box-63"/>
+          <p:cNvPr id="10" name="box-67"/>
           <p:cNvSpPr txBox="1"/>
           <p:nvPr/>
         </p:nvSpPr>
@@ -3336,7 +3410,7 @@
       </p:sp>
       <p:sp>
         <p:nvSpPr>
-          <p:cNvPr id="11" name="box-64"/>
+          <p:cNvPr id="11" name="box-68"/>
           <p:cNvSpPr txBox="1"/>
           <p:nvPr/>
         </p:nvSpPr>
@@ -3376,7 +3450,7 @@
       </p:sp>
       <p:sp>
         <p:nvSpPr>
-          <p:cNvPr id="12" name="box-65"/>
+          <p:cNvPr id="12" name="box-69"/>
           <p:cNvSpPr txBox="1"/>
           <p:nvPr/>
         </p:nvSpPr>
@@ -3416,7 +3490,7 @@
       </p:sp>
       <p:sp>
         <p:nvSpPr>
-          <p:cNvPr id="13" name="box-66"/>
+          <p:cNvPr id="13" name="box-70"/>
           <p:cNvSpPr txBox="1"/>
           <p:nvPr/>
         </p:nvSpPr>
@@ -3456,7 +3530,7 @@
       </p:sp>
       <p:sp>
         <p:nvSpPr>
-          <p:cNvPr id="14" name="box-67"/>
+          <p:cNvPr id="14" name="box-71"/>
           <p:cNvSpPr txBox="1"/>
           <p:nvPr/>
         </p:nvSpPr>
@@ -3496,7 +3570,7 @@
       </p:sp>
       <p:sp>
         <p:nvSpPr>
-          <p:cNvPr id="15" name="box-68"/>
+          <p:cNvPr id="15" name="box-72"/>
           <p:cNvSpPr txBox="1"/>
           <p:nvPr/>
         </p:nvSpPr>
@@ -3536,7 +3610,7 @@
       </p:sp>
       <p:sp>
         <p:nvSpPr>
-          <p:cNvPr id="16" name="box-69"/>
+          <p:cNvPr id="16" name="box-73"/>
           <p:cNvSpPr txBox="1"/>
           <p:nvPr/>
         </p:nvSpPr>
@@ -3576,7 +3650,7 @@
       </p:sp>
       <p:sp>
         <p:nvSpPr>
-          <p:cNvPr id="17" name="box-70"/>
+          <p:cNvPr id="17" name="box-74"/>
           <p:cNvSpPr txBox="1"/>
           <p:nvPr/>
         </p:nvSpPr>
@@ -3616,7 +3690,7 @@
       </p:sp>
       <p:sp>
         <p:nvSpPr>
-          <p:cNvPr id="18" name="box-71"/>
+          <p:cNvPr id="18" name="box-75"/>
           <p:cNvSpPr txBox="1"/>
           <p:nvPr/>
         </p:nvSpPr>
@@ -3656,7 +3730,7 @@
       </p:sp>
       <p:sp>
         <p:nvSpPr>
-          <p:cNvPr id="19" name="box-72"/>
+          <p:cNvPr id="19" name="box-76"/>
           <p:cNvSpPr txBox="1"/>
           <p:nvPr/>
         </p:nvSpPr>
@@ -3696,7 +3770,7 @@
       </p:sp>
       <p:sp>
         <p:nvSpPr>
-          <p:cNvPr id="20" name="box-73"/>
+          <p:cNvPr id="20" name="box-77"/>
           <p:cNvSpPr txBox="1"/>
           <p:nvPr/>
         </p:nvSpPr>
@@ -3736,7 +3810,7 @@
       </p:sp>
       <p:sp>
         <p:nvSpPr>
-          <p:cNvPr id="21" name="text-74"/>
+          <p:cNvPr id="21" name="text-78"/>
           <p:cNvSpPr txBox="1"/>
           <p:nvPr/>
         </p:nvSpPr>
@@ -3842,7 +3916,7 @@
       </p:grpSpPr>
       <p:sp>
         <p:nvSpPr>
-          <p:cNvPr id="2" name="titel-75"/>
+          <p:cNvPr id="2" name="titel-79"/>
           <p:cNvSpPr txBox="1"/>
           <p:nvPr/>
         </p:nvSpPr>
@@ -3878,7 +3952,7 @@
       </p:sp>
       <p:sp>
         <p:nvSpPr>
-          <p:cNvPr id="3" name="aufgabe-76"/>
+          <p:cNvPr id="3" name="aufgabe-80"/>
           <p:cNvSpPr txBox="1"/>
           <p:nvPr/>
         </p:nvSpPr>
@@ -3954,7 +4028,7 @@
       </p:sp>
       <p:sp>
         <p:nvSpPr>
-          <p:cNvPr id="4" name="aufgabe-77"/>
+          <p:cNvPr id="4" name="aufgabe-81"/>
           <p:cNvSpPr txBox="1"/>
           <p:nvPr/>
         </p:nvSpPr>
@@ -4083,7 +4157,7 @@
       </p:grpSpPr>
       <p:sp>
         <p:nvSpPr>
-          <p:cNvPr id="2" name="titel-78"/>
+          <p:cNvPr id="2" name="titel-82"/>
           <p:cNvSpPr txBox="1"/>
           <p:nvPr/>
         </p:nvSpPr>
@@ -4119,7 +4193,7 @@
       </p:sp>
       <p:sp>
         <p:nvSpPr>
-          <p:cNvPr id="3" name="quote-79"/>
+          <p:cNvPr id="3" name="quote-83"/>
           <p:cNvSpPr txBox="1"/>
           <p:nvPr/>
         </p:nvSpPr>
@@ -4244,7 +4318,7 @@
       </p:grpSpPr>
       <p:sp>
         <p:nvSpPr>
-          <p:cNvPr id="2" name="titel-80"/>
+          <p:cNvPr id="2" name="titel-84"/>
           <p:cNvSpPr txBox="1"/>
           <p:nvPr/>
         </p:nvSpPr>
@@ -4280,7 +4354,7 @@
       </p:sp>
       <p:sp>
         <p:nvSpPr>
-          <p:cNvPr id="3" name="link-81"/>
+          <p:cNvPr id="3" name="link-85"/>
           <p:cNvSpPr txBox="1"/>
           <p:nvPr/>
         </p:nvSpPr>
@@ -4334,7 +4408,7 @@
       </p:sp>
       <p:sp>
         <p:nvSpPr>
-          <p:cNvPr id="4" name="aufgabe-82"/>
+          <p:cNvPr id="4" name="aufgabe-86"/>
           <p:cNvSpPr txBox="1"/>
           <p:nvPr/>
         </p:nvSpPr>
@@ -4393,7 +4467,7 @@
       </p:sp>
       <p:sp>
         <p:nvSpPr>
-          <p:cNvPr id="5" name="aufgabe-83"/>
+          <p:cNvPr id="5" name="aufgabe-87"/>
           <p:cNvSpPr txBox="1"/>
           <p:nvPr/>
         </p:nvSpPr>
@@ -4522,7 +4596,7 @@
       </p:grpSpPr>
       <p:sp>
         <p:nvSpPr>
-          <p:cNvPr id="2" name="titel-84"/>
+          <p:cNvPr id="2" name="titel-88"/>
           <p:cNvSpPr txBox="1"/>
           <p:nvPr/>
         </p:nvSpPr>
@@ -4558,7 +4632,7 @@
       </p:sp>
       <p:sp>
         <p:nvSpPr>
-          <p:cNvPr id="3" name="box-85"/>
+          <p:cNvPr id="3" name="box-89"/>
           <p:cNvSpPr txBox="1"/>
           <p:nvPr/>
         </p:nvSpPr>
@@ -4600,7 +4674,7 @@
       </p:sp>
       <p:sp>
         <p:nvSpPr>
-          <p:cNvPr id="4" name="arrow-86"/>
+          <p:cNvPr id="4" name="arrow-90"/>
           <p:cNvSpPr/>
           <p:nvPr/>
         </p:nvSpPr>
@@ -4624,7 +4698,7 @@
       </p:sp>
       <p:sp>
         <p:nvSpPr>
-          <p:cNvPr id="5" name="box-87"/>
+          <p:cNvPr id="5" name="box-91"/>
           <p:cNvSpPr txBox="1"/>
           <p:nvPr/>
         </p:nvSpPr>
@@ -4666,7 +4740,7 @@
       </p:sp>
       <p:sp>
         <p:nvSpPr>
-          <p:cNvPr id="6" name="aufgabe-88"/>
+          <p:cNvPr id="6" name="aufgabe-92"/>
           <p:cNvSpPr txBox="1"/>
           <p:nvPr/>
         </p:nvSpPr>
@@ -4725,7 +4799,7 @@
       </p:sp>
       <p:sp>
         <p:nvSpPr>
-          <p:cNvPr id="7" name="aufgabe-89"/>
+          <p:cNvPr id="7" name="aufgabe-93"/>
           <p:cNvSpPr txBox="1"/>
           <p:nvPr/>
         </p:nvSpPr>
@@ -4784,7 +4858,7 @@
       </p:sp>
       <p:sp>
         <p:nvSpPr>
-          <p:cNvPr id="8" name="aufgabe-90"/>
+          <p:cNvPr id="8" name="aufgabe-94"/>
           <p:cNvSpPr txBox="1"/>
           <p:nvPr/>
         </p:nvSpPr>
@@ -4913,7 +4987,7 @@
       </p:grpSpPr>
       <p:sp>
         <p:nvSpPr>
-          <p:cNvPr id="2" name="titel-91"/>
+          <p:cNvPr id="2" name="titel-95"/>
           <p:cNvSpPr txBox="1"/>
           <p:nvPr/>
         </p:nvSpPr>
@@ -4949,7 +5023,7 @@
       </p:sp>
       <p:sp>
         <p:nvSpPr>
-          <p:cNvPr id="3" name="text-92"/>
+          <p:cNvPr id="3" name="text-96"/>
           <p:cNvSpPr txBox="1"/>
           <p:nvPr/>
         </p:nvSpPr>
@@ -4985,7 +5059,7 @@
       </p:sp>
       <p:sp>
         <p:nvSpPr>
-          <p:cNvPr id="4" name="box-93"/>
+          <p:cNvPr id="4" name="box-97"/>
           <p:cNvSpPr txBox="1"/>
           <p:nvPr/>
         </p:nvSpPr>
@@ -5023,7 +5097,7 @@
       </p:sp>
       <p:sp>
         <p:nvSpPr>
-          <p:cNvPr id="5" name="box-94"/>
+          <p:cNvPr id="5" name="box-98"/>
           <p:cNvSpPr txBox="1"/>
           <p:nvPr/>
         </p:nvSpPr>
@@ -5061,7 +5135,7 @@
       </p:sp>
       <p:sp>
         <p:nvSpPr>
-          <p:cNvPr id="6" name="box-95"/>
+          <p:cNvPr id="6" name="box-99"/>
           <p:cNvSpPr txBox="1"/>
           <p:nvPr/>
         </p:nvSpPr>
@@ -5099,7 +5173,7 @@
       </p:sp>
       <p:sp>
         <p:nvSpPr>
-          <p:cNvPr id="7" name="box-96"/>
+          <p:cNvPr id="7" name="box-100"/>
           <p:cNvSpPr txBox="1"/>
           <p:nvPr/>
         </p:nvSpPr>
@@ -5137,7 +5211,7 @@
       </p:sp>
       <p:sp>
         <p:nvSpPr>
-          <p:cNvPr id="8" name="box-97"/>
+          <p:cNvPr id="8" name="box-101"/>
           <p:cNvSpPr txBox="1"/>
           <p:nvPr/>
         </p:nvSpPr>
@@ -5175,7 +5249,7 @@
       </p:sp>
       <p:sp>
         <p:nvSpPr>
-          <p:cNvPr id="9" name="box-98"/>
+          <p:cNvPr id="9" name="box-102"/>
           <p:cNvSpPr txBox="1"/>
           <p:nvPr/>
         </p:nvSpPr>
@@ -5213,7 +5287,7 @@
       </p:sp>
       <p:sp>
         <p:nvSpPr>
-          <p:cNvPr id="10" name="box-99"/>
+          <p:cNvPr id="10" name="box-103"/>
           <p:cNvSpPr txBox="1"/>
           <p:nvPr/>
         </p:nvSpPr>
@@ -5251,7 +5325,7 @@
       </p:sp>
       <p:sp>
         <p:nvSpPr>
-          <p:cNvPr id="11" name="box-100"/>
+          <p:cNvPr id="11" name="box-104"/>
           <p:cNvSpPr txBox="1"/>
           <p:nvPr/>
         </p:nvSpPr>
@@ -5289,7 +5363,7 @@
       </p:sp>
       <p:sp>
         <p:nvSpPr>
-          <p:cNvPr id="12" name="box-101"/>
+          <p:cNvPr id="12" name="box-105"/>
           <p:cNvSpPr txBox="1"/>
           <p:nvPr/>
         </p:nvSpPr>
@@ -5327,7 +5401,7 @@
       </p:sp>
       <p:sp>
         <p:nvSpPr>
-          <p:cNvPr id="13" name="box-102"/>
+          <p:cNvPr id="13" name="box-106"/>
           <p:cNvSpPr txBox="1"/>
           <p:nvPr/>
         </p:nvSpPr>
@@ -5365,7 +5439,7 @@
       </p:sp>
       <p:sp>
         <p:nvSpPr>
-          <p:cNvPr id="14" name="box-103"/>
+          <p:cNvPr id="14" name="box-107"/>
           <p:cNvSpPr txBox="1"/>
           <p:nvPr/>
         </p:nvSpPr>
@@ -5403,7 +5477,7 @@
       </p:sp>
       <p:sp>
         <p:nvSpPr>
-          <p:cNvPr id="15" name="box-104"/>
+          <p:cNvPr id="15" name="box-108"/>
           <p:cNvSpPr txBox="1"/>
           <p:nvPr/>
         </p:nvSpPr>
@@ -5441,7 +5515,7 @@
       </p:sp>
       <p:sp>
         <p:nvSpPr>
-          <p:cNvPr id="16" name="aufgabe-105"/>
+          <p:cNvPr id="16" name="aufgabe-109"/>
           <p:cNvSpPr txBox="1"/>
           <p:nvPr/>
         </p:nvSpPr>
@@ -5570,7 +5644,7 @@
       </p:grpSpPr>
       <p:sp>
         <p:nvSpPr>
-          <p:cNvPr id="2" name="titel-106"/>
+          <p:cNvPr id="2" name="titel-110"/>
           <p:cNvSpPr txBox="1"/>
           <p:nvPr/>
         </p:nvSpPr>
@@ -5606,7 +5680,7 @@
       </p:sp>
       <p:sp>
         <p:nvSpPr>
-          <p:cNvPr id="3" name="tile-107"/>
+          <p:cNvPr id="3" name="tile-111"/>
           <p:cNvSpPr txBox="1"/>
           <p:nvPr/>
         </p:nvSpPr>
@@ -5665,7 +5739,7 @@
       </p:sp>
       <p:sp>
         <p:nvSpPr>
-          <p:cNvPr id="4" name="tile-108"/>
+          <p:cNvPr id="4" name="tile-112"/>
           <p:cNvSpPr txBox="1"/>
           <p:nvPr/>
         </p:nvSpPr>
@@ -5724,7 +5798,7 @@
       </p:sp>
       <p:sp>
         <p:nvSpPr>
-          <p:cNvPr id="5" name="list-109"/>
+          <p:cNvPr id="5" name="list-113"/>
           <p:cNvSpPr txBox="1"/>
           <p:nvPr/>
         </p:nvSpPr>
@@ -5852,7 +5926,7 @@
       </p:grpSpPr>
       <p:sp>
         <p:nvSpPr>
-          <p:cNvPr id="2" name="titel-110"/>
+          <p:cNvPr id="2" name="titel-114"/>
           <p:cNvSpPr txBox="1"/>
           <p:nvPr/>
         </p:nvSpPr>
@@ -5888,7 +5962,7 @@
       </p:sp>
       <p:sp>
         <p:nvSpPr>
-          <p:cNvPr id="3" name="text-111"/>
+          <p:cNvPr id="3" name="text-115"/>
           <p:cNvSpPr txBox="1"/>
           <p:nvPr/>
         </p:nvSpPr>
@@ -5924,7 +5998,7 @@
       </p:sp>
       <p:sp>
         <p:nvSpPr>
-          <p:cNvPr id="4" name="link-112"/>
+          <p:cNvPr id="4" name="link-116"/>
           <p:cNvSpPr txBox="1"/>
           <p:nvPr/>
         </p:nvSpPr>
@@ -5967,7 +6041,7 @@
       </p:sp>
       <p:sp>
         <p:nvSpPr>
-          <p:cNvPr id="5" name="list-113"/>
+          <p:cNvPr id="5" name="list-117"/>
           <p:cNvSpPr txBox="1"/>
           <p:nvPr/>
         </p:nvSpPr>
@@ -6043,7 +6117,7 @@
       </p:sp>
       <p:pic>
         <p:nvPicPr>
-          <p:cNvPr id="6" name="qr-114" descr="QR-Code zur Kursseite: https://t1p.de/tdk-26">    </p:cNvPr>
+          <p:cNvPr id="6" name="qr-118" descr="QR-Code zur Kursseite: https://t1p.de/tdk-26">    </p:cNvPr>
           <p:cNvPicPr>
             <a:picLocks noChangeAspect="1"/>
           </p:cNvPicPr>
@@ -6067,7 +6141,7 @@
       </p:pic>
       <p:sp>
         <p:nvSpPr>
-          <p:cNvPr id="7" name="text-115"/>
+          <p:cNvPr id="7" name="text-119"/>
           <p:cNvSpPr txBox="1"/>
           <p:nvPr/>
         </p:nvSpPr>
@@ -6173,7 +6247,7 @@
       </p:grpSpPr>
       <p:sp>
         <p:nvSpPr>
-          <p:cNvPr id="2" name="titel-9"/>
+          <p:cNvPr id="2" name="titel-11"/>
           <p:cNvSpPr txBox="1"/>
           <p:nvPr/>
         </p:nvSpPr>
@@ -6209,7 +6283,7 @@
       </p:sp>
       <p:sp>
         <p:nvSpPr>
-          <p:cNvPr id="3" name="text-10"/>
+          <p:cNvPr id="3" name="text-12"/>
           <p:cNvSpPr txBox="1"/>
           <p:nvPr/>
         </p:nvSpPr>
@@ -6245,7 +6319,7 @@
       </p:sp>
       <p:sp>
         <p:nvSpPr>
-          <p:cNvPr id="4" name="box-11"/>
+          <p:cNvPr id="4" name="box-13"/>
           <p:cNvSpPr txBox="1"/>
           <p:nvPr/>
         </p:nvSpPr>
@@ -6353,7 +6427,7 @@
       </p:grpSpPr>
       <p:sp>
         <p:nvSpPr>
-          <p:cNvPr id="2" name="titel-12"/>
+          <p:cNvPr id="2" name="titel-14"/>
           <p:cNvSpPr txBox="1"/>
           <p:nvPr/>
         </p:nvSpPr>
@@ -6389,7 +6463,7 @@
       </p:sp>
       <p:sp>
         <p:nvSpPr>
-          <p:cNvPr id="3" name="box-13"/>
+          <p:cNvPr id="3" name="box-15"/>
           <p:cNvSpPr txBox="1"/>
           <p:nvPr/>
         </p:nvSpPr>
@@ -6427,7 +6501,7 @@
       </p:sp>
       <p:sp>
         <p:nvSpPr>
-          <p:cNvPr id="4" name="box-14"/>
+          <p:cNvPr id="4" name="box-16"/>
           <p:cNvSpPr txBox="1"/>
           <p:nvPr/>
         </p:nvSpPr>
@@ -6465,7 +6539,7 @@
       </p:sp>
       <p:sp>
         <p:nvSpPr>
-          <p:cNvPr id="5" name="box-15"/>
+          <p:cNvPr id="5" name="box-17"/>
           <p:cNvSpPr txBox="1"/>
           <p:nvPr/>
         </p:nvSpPr>
@@ -6503,7 +6577,7 @@
       </p:sp>
       <p:sp>
         <p:nvSpPr>
-          <p:cNvPr id="6" name="box-16"/>
+          <p:cNvPr id="6" name="box-18"/>
           <p:cNvSpPr txBox="1"/>
           <p:nvPr/>
         </p:nvSpPr>
@@ -6541,7 +6615,7 @@
       </p:sp>
       <p:sp>
         <p:nvSpPr>
-          <p:cNvPr id="7" name="box-17"/>
+          <p:cNvPr id="7" name="box-19"/>
           <p:cNvSpPr txBox="1"/>
           <p:nvPr/>
         </p:nvSpPr>
@@ -6579,7 +6653,7 @@
       </p:sp>
       <p:sp>
         <p:nvSpPr>
-          <p:cNvPr id="8" name="box-18"/>
+          <p:cNvPr id="8" name="box-20"/>
           <p:cNvSpPr txBox="1"/>
           <p:nvPr/>
         </p:nvSpPr>
@@ -6617,7 +6691,7 @@
       </p:sp>
       <p:sp>
         <p:nvSpPr>
-          <p:cNvPr id="9" name="box-19"/>
+          <p:cNvPr id="9" name="box-21"/>
           <p:cNvSpPr txBox="1"/>
           <p:nvPr/>
         </p:nvSpPr>
@@ -6655,7 +6729,7 @@
       </p:sp>
       <p:sp>
         <p:nvSpPr>
-          <p:cNvPr id="10" name="box-20"/>
+          <p:cNvPr id="10" name="box-22"/>
           <p:cNvSpPr txBox="1"/>
           <p:nvPr/>
         </p:nvSpPr>
@@ -6763,7 +6837,7 @@
       </p:grpSpPr>
       <p:sp>
         <p:nvSpPr>
-          <p:cNvPr id="2" name="titel-21"/>
+          <p:cNvPr id="2" name="titel-23"/>
           <p:cNvSpPr txBox="1"/>
           <p:nvPr/>
         </p:nvSpPr>
@@ -6799,7 +6873,7 @@
       </p:sp>
       <p:sp>
         <p:nvSpPr>
-          <p:cNvPr id="3" name="text-22"/>
+          <p:cNvPr id="3" name="text-24"/>
           <p:cNvSpPr txBox="1"/>
           <p:nvPr/>
         </p:nvSpPr>
@@ -6835,7 +6909,7 @@
       </p:sp>
       <p:sp>
         <p:nvSpPr>
-          <p:cNvPr id="4" name="text-23"/>
+          <p:cNvPr id="4" name="text-25"/>
           <p:cNvSpPr txBox="1"/>
           <p:nvPr/>
         </p:nvSpPr>
@@ -6871,7 +6945,7 @@
       </p:sp>
       <p:sp>
         <p:nvSpPr>
-          <p:cNvPr id="5" name="tile-24"/>
+          <p:cNvPr id="5" name="tile-26"/>
           <p:cNvSpPr txBox="1"/>
           <p:nvPr/>
         </p:nvSpPr>
@@ -6949,7 +7023,7 @@
       </p:sp>
       <p:sp>
         <p:nvSpPr>
-          <p:cNvPr id="6" name="tile-25"/>
+          <p:cNvPr id="6" name="tile-27"/>
           <p:cNvSpPr txBox="1"/>
           <p:nvPr/>
         </p:nvSpPr>
@@ -7027,7 +7101,7 @@
       </p:sp>
       <p:sp>
         <p:nvSpPr>
-          <p:cNvPr id="7" name="box-26"/>
+          <p:cNvPr id="7" name="box-28"/>
           <p:cNvSpPr txBox="1"/>
           <p:nvPr/>
         </p:nvSpPr>
@@ -7065,7 +7139,7 @@
       </p:sp>
       <p:sp>
         <p:nvSpPr>
-          <p:cNvPr id="8" name="text-27"/>
+          <p:cNvPr id="8" name="text-29"/>
           <p:cNvSpPr txBox="1"/>
           <p:nvPr/>
         </p:nvSpPr>
@@ -7171,7 +7245,7 @@
       </p:grpSpPr>
       <p:sp>
         <p:nvSpPr>
-          <p:cNvPr id="2" name="titel-28"/>
+          <p:cNvPr id="2" name="titel-30"/>
           <p:cNvSpPr txBox="1"/>
           <p:nvPr/>
         </p:nvSpPr>
@@ -7207,7 +7281,7 @@
       </p:sp>
       <p:sp>
         <p:nvSpPr>
-          <p:cNvPr id="3" name="box-29"/>
+          <p:cNvPr id="3" name="box-31"/>
           <p:cNvSpPr txBox="1"/>
           <p:nvPr/>
         </p:nvSpPr>
@@ -7245,7 +7319,7 @@
       </p:sp>
       <p:sp>
         <p:nvSpPr>
-          <p:cNvPr id="4" name="text-30"/>
+          <p:cNvPr id="4" name="text-32"/>
           <p:cNvSpPr txBox="1"/>
           <p:nvPr/>
         </p:nvSpPr>
@@ -7351,7 +7425,7 @@
       </p:grpSpPr>
       <p:sp>
         <p:nvSpPr>
-          <p:cNvPr id="2" name="titel-31"/>
+          <p:cNvPr id="2" name="titel-33"/>
           <p:cNvSpPr txBox="1"/>
           <p:nvPr/>
         </p:nvSpPr>
@@ -7387,14 +7461,14 @@
       </p:sp>
       <p:sp>
         <p:nvSpPr>
-          <p:cNvPr id="3" name="step-32"/>
+          <p:cNvPr id="3" name="step-34"/>
           <p:cNvSpPr txBox="1"/>
           <p:nvPr/>
         </p:nvSpPr>
         <p:spPr>
           <a:xfrm>
             <a:off x="548640" y="1783080"/>
-            <a:ext cx="2464994" cy="2377440"/>
+            <a:ext cx="1889699" cy="2377440"/>
           </a:xfrm>
           <a:prstGeom prst="rect">
             <a:avLst/>
@@ -7416,14 +7490,14 @@
               <a:buNone/>
             </a:pPr>
             <a:r>
-              <a:rPr lang="en-US" sz="2200" b="1" dirty="0">
+              <a:rPr lang="en-US" sz="2000" b="1" dirty="0">
                 <a:solidFill>
                   <a:srgbClr val="035591"/>
                 </a:solidFill>
               </a:rPr>
               <a:t>Termin 1</a:t>
             </a:r>
-            <a:endParaRPr lang="en-US" sz="2200" dirty="0"/>
+            <a:endParaRPr lang="en-US" sz="2000" dirty="0"/>
           </a:p>
           <a:p>
             <a:pPr indent="0" marL="0">
@@ -7433,26 +7507,26 @@
               <a:buNone/>
             </a:pPr>
             <a:r>
-              <a:rPr lang="en-US" sz="1900" dirty="0">
-                <a:solidFill>
-                  <a:srgbClr val="14232F"/>
-                </a:solidFill>
-              </a:rPr>
-              <a:t>Einführung · Aufgabenpaket 1 bekommen</a:t>
-            </a:r>
-            <a:endParaRPr lang="en-US" sz="2200" dirty="0"/>
-          </a:p>
-        </p:txBody>
-      </p:sp>
-      <p:sp>
-        <p:nvSpPr>
-          <p:cNvPr id="4" name="arrow-33"/>
+              <a:rPr lang="en-US" sz="1800" dirty="0">
+                <a:solidFill>
+                  <a:srgbClr val="14232F"/>
+                </a:solidFill>
+              </a:rPr>
+              <a:t>Einführung · Aufgabenpaket 1</a:t>
+            </a:r>
+            <a:endParaRPr lang="en-US" sz="2000" dirty="0"/>
+          </a:p>
+        </p:txBody>
+      </p:sp>
+      <p:sp>
+        <p:nvSpPr>
+          <p:cNvPr id="4" name="arrow-35"/>
           <p:cNvSpPr/>
           <p:nvPr/>
         </p:nvSpPr>
         <p:spPr>
           <a:xfrm>
-            <a:off x="3068498" y="2971800"/>
+            <a:off x="2493203" y="2971800"/>
             <a:ext cx="301752" cy="914"/>
           </a:xfrm>
           <a:prstGeom prst="line">
@@ -7470,14 +7544,14 @@
       </p:sp>
       <p:sp>
         <p:nvSpPr>
-          <p:cNvPr id="5" name="step-34"/>
-          <p:cNvSpPr txBox="1"/>
-          <p:nvPr/>
-        </p:nvSpPr>
-        <p:spPr>
-          <a:xfrm>
-            <a:off x="3425114" y="1783080"/>
-            <a:ext cx="2464994" cy="2377440"/>
+          <p:cNvPr id="5" name="step-36"/>
+          <p:cNvSpPr txBox="1"/>
+          <p:nvPr/>
+        </p:nvSpPr>
+        <p:spPr>
+          <a:xfrm>
+            <a:off x="2849819" y="1783080"/>
+            <a:ext cx="1889699" cy="2377440"/>
           </a:xfrm>
           <a:prstGeom prst="rect">
             <a:avLst/>
@@ -7499,14 +7573,14 @@
               <a:buNone/>
             </a:pPr>
             <a:r>
-              <a:rPr lang="en-US" sz="2200" b="1" dirty="0">
+              <a:rPr lang="en-US" sz="2000" b="1" dirty="0">
                 <a:solidFill>
                   <a:srgbClr val="035591"/>
                 </a:solidFill>
               </a:rPr>
               <a:t>Termin 2</a:t>
             </a:r>
-            <a:endParaRPr lang="en-US" sz="2200" dirty="0"/>
+            <a:endParaRPr lang="en-US" sz="2000" dirty="0"/>
           </a:p>
           <a:p>
             <a:pPr indent="0" marL="0">
@@ -7516,26 +7590,26 @@
               <a:buNone/>
             </a:pPr>
             <a:r>
-              <a:rPr lang="en-US" sz="1900" dirty="0">
+              <a:rPr lang="en-US" sz="1800" dirty="0">
                 <a:solidFill>
                   <a:srgbClr val="14232F"/>
                 </a:solidFill>
               </a:rPr>
               <a:t>Paket 1 besprechen · Aufgabenpaket 2</a:t>
             </a:r>
-            <a:endParaRPr lang="en-US" sz="2200" dirty="0"/>
-          </a:p>
-        </p:txBody>
-      </p:sp>
-      <p:sp>
-        <p:nvSpPr>
-          <p:cNvPr id="6" name="arrow-35"/>
+            <a:endParaRPr lang="en-US" sz="2000" dirty="0"/>
+          </a:p>
+        </p:txBody>
+      </p:sp>
+      <p:sp>
+        <p:nvSpPr>
+          <p:cNvPr id="6" name="arrow-37"/>
           <p:cNvSpPr/>
           <p:nvPr/>
         </p:nvSpPr>
         <p:spPr>
           <a:xfrm>
-            <a:off x="5944972" y="2971800"/>
+            <a:off x="4794382" y="2971800"/>
             <a:ext cx="301752" cy="914"/>
           </a:xfrm>
           <a:prstGeom prst="line">
@@ -7553,14 +7627,14 @@
       </p:sp>
       <p:sp>
         <p:nvSpPr>
-          <p:cNvPr id="7" name="step-36"/>
-          <p:cNvSpPr txBox="1"/>
-          <p:nvPr/>
-        </p:nvSpPr>
-        <p:spPr>
-          <a:xfrm>
-            <a:off x="6301588" y="1783080"/>
-            <a:ext cx="2464994" cy="2377440"/>
+          <p:cNvPr id="7" name="step-38"/>
+          <p:cNvSpPr txBox="1"/>
+          <p:nvPr/>
+        </p:nvSpPr>
+        <p:spPr>
+          <a:xfrm>
+            <a:off x="5150998" y="1783080"/>
+            <a:ext cx="1889699" cy="2377440"/>
           </a:xfrm>
           <a:prstGeom prst="rect">
             <a:avLst/>
@@ -7582,14 +7656,14 @@
               <a:buNone/>
             </a:pPr>
             <a:r>
-              <a:rPr lang="en-US" sz="2200" b="1" dirty="0">
+              <a:rPr lang="en-US" sz="2000" b="1" dirty="0">
                 <a:solidFill>
                   <a:srgbClr val="035591"/>
                 </a:solidFill>
               </a:rPr>
               <a:t>Termin 3</a:t>
             </a:r>
-            <a:endParaRPr lang="en-US" sz="2200" dirty="0"/>
+            <a:endParaRPr lang="en-US" sz="2000" dirty="0"/>
           </a:p>
           <a:p>
             <a:pPr indent="0" marL="0">
@@ -7599,26 +7673,26 @@
               <a:buNone/>
             </a:pPr>
             <a:r>
-              <a:rPr lang="en-US" sz="1900" dirty="0">
-                <a:solidFill>
-                  <a:srgbClr val="14232F"/>
-                </a:solidFill>
-              </a:rPr>
-              <a:t>Paket 2 besprechen · Gespräch aktuelle Entwicklungen · Referat + Diskussion</a:t>
-            </a:r>
-            <a:endParaRPr lang="en-US" sz="2200" dirty="0"/>
-          </a:p>
-        </p:txBody>
-      </p:sp>
-      <p:sp>
-        <p:nvSpPr>
-          <p:cNvPr id="8" name="arrow-37"/>
+              <a:rPr lang="en-US" sz="1800" dirty="0">
+                <a:solidFill>
+                  <a:srgbClr val="14232F"/>
+                </a:solidFill>
+              </a:rPr>
+              <a:t>Paket 2 besprechen · Gespräch aktuelle Entwicklungen</a:t>
+            </a:r>
+            <a:endParaRPr lang="en-US" sz="2000" dirty="0"/>
+          </a:p>
+        </p:txBody>
+      </p:sp>
+      <p:sp>
+        <p:nvSpPr>
+          <p:cNvPr id="8" name="arrow-39"/>
           <p:cNvSpPr/>
           <p:nvPr/>
         </p:nvSpPr>
         <p:spPr>
           <a:xfrm>
-            <a:off x="8821445" y="2971800"/>
+            <a:off x="7095561" y="2971800"/>
             <a:ext cx="301752" cy="914"/>
           </a:xfrm>
           <a:prstGeom prst="line">
@@ -7636,14 +7710,14 @@
       </p:sp>
       <p:sp>
         <p:nvSpPr>
-          <p:cNvPr id="9" name="step-38"/>
-          <p:cNvSpPr txBox="1"/>
-          <p:nvPr/>
-        </p:nvSpPr>
-        <p:spPr>
-          <a:xfrm>
-            <a:off x="9178061" y="1783080"/>
-            <a:ext cx="2464994" cy="2377440"/>
+          <p:cNvPr id="9" name="step-40"/>
+          <p:cNvSpPr txBox="1"/>
+          <p:nvPr/>
+        </p:nvSpPr>
+        <p:spPr>
+          <a:xfrm>
+            <a:off x="7452177" y="1783080"/>
+            <a:ext cx="1889699" cy="2377440"/>
           </a:xfrm>
           <a:prstGeom prst="rect">
             <a:avLst/>
@@ -7665,14 +7739,14 @@
               <a:buNone/>
             </a:pPr>
             <a:r>
-              <a:rPr lang="en-US" sz="2200" b="1" dirty="0">
+              <a:rPr lang="en-US" sz="2000" b="1" dirty="0">
                 <a:solidFill>
                   <a:srgbClr val="035591"/>
                 </a:solidFill>
               </a:rPr>
-              <a:t>Danach</a:t>
-            </a:r>
-            <a:endParaRPr lang="en-US" sz="2200" dirty="0"/>
+              <a:t>Termin 4</a:t>
+            </a:r>
+            <a:endParaRPr lang="en-US" sz="2000" dirty="0"/>
           </a:p>
           <a:p>
             <a:pPr indent="0" marL="0">
@@ -7682,20 +7756,103 @@
               <a:buNone/>
             </a:pPr>
             <a:r>
-              <a:rPr lang="en-US" sz="1900" dirty="0">
+              <a:rPr lang="en-US" sz="1800" dirty="0">
+                <a:solidFill>
+                  <a:srgbClr val="14232F"/>
+                </a:solidFill>
+              </a:rPr>
+              <a:t>dein Referat oder Vortrag + Diskussion</a:t>
+            </a:r>
+            <a:endParaRPr lang="en-US" sz="2000" dirty="0"/>
+          </a:p>
+        </p:txBody>
+      </p:sp>
+      <p:sp>
+        <p:nvSpPr>
+          <p:cNvPr id="10" name="arrow-41"/>
+          <p:cNvSpPr/>
+          <p:nvPr/>
+        </p:nvSpPr>
+        <p:spPr>
+          <a:xfrm>
+            <a:off x="9396740" y="2971800"/>
+            <a:ext cx="301752" cy="914"/>
+          </a:xfrm>
+          <a:prstGeom prst="line">
+            <a:avLst/>
+          </a:prstGeom>
+          <a:noFill/>
+          <a:ln w="25400">
+            <a:solidFill>
+              <a:srgbClr val="035591"/>
+            </a:solidFill>
+            <a:prstDash val="solid"/>
+            <a:tailEnd type="triangle"/>
+          </a:ln>
+        </p:spPr>
+      </p:sp>
+      <p:sp>
+        <p:nvSpPr>
+          <p:cNvPr id="11" name="step-42"/>
+          <p:cNvSpPr txBox="1"/>
+          <p:nvPr/>
+        </p:nvSpPr>
+        <p:spPr>
+          <a:xfrm>
+            <a:off x="9753356" y="1783080"/>
+            <a:ext cx="1889699" cy="2377440"/>
+          </a:xfrm>
+          <a:prstGeom prst="rect">
+            <a:avLst/>
+          </a:prstGeom>
+          <a:solidFill>
+            <a:srgbClr val="FFFFFF"/>
+          </a:solidFill>
+          <a:ln w="25400">
+            <a:solidFill>
+              <a:srgbClr val="035591"/>
+            </a:solidFill>
+          </a:ln>
+        </p:spPr>
+        <p:txBody>
+          <a:bodyPr wrap="square" lIns="114300" tIns="114300" rIns="114300" bIns="114300" rtlCol="0" anchor="t"/>
+          <a:lstStyle/>
+          <a:p>
+            <a:pPr indent="0" marL="0">
+              <a:buNone/>
+            </a:pPr>
+            <a:r>
+              <a:rPr lang="en-US" sz="2000" b="1" dirty="0">
+                <a:solidFill>
+                  <a:srgbClr val="035591"/>
+                </a:solidFill>
+              </a:rPr>
+              <a:t>Danach</a:t>
+            </a:r>
+            <a:endParaRPr lang="en-US" sz="2000" dirty="0"/>
+          </a:p>
+          <a:p>
+            <a:pPr indent="0" marL="0">
+              <a:spcBef>
+                <a:spcPts val="400"/>
+              </a:spcBef>
+              <a:buNone/>
+            </a:pPr>
+            <a:r>
+              <a:rPr lang="en-US" sz="1800" dirty="0">
                 <a:solidFill>
                   <a:srgbClr val="14232F"/>
                 </a:solidFill>
               </a:rPr>
               <a:t>Ausarbeitung (Weg A)</a:t>
             </a:r>
-            <a:endParaRPr lang="en-US" sz="2200" dirty="0"/>
-          </a:p>
-        </p:txBody>
-      </p:sp>
-      <p:sp>
-        <p:nvSpPr>
-          <p:cNvPr id="10" name="box-39"/>
+            <a:endParaRPr lang="en-US" sz="2000" dirty="0"/>
+          </a:p>
+        </p:txBody>
+      </p:sp>
+      <p:sp>
+        <p:nvSpPr>
+          <p:cNvPr id="12" name="box-43"/>
           <p:cNvSpPr txBox="1"/>
           <p:nvPr/>
         </p:nvSpPr>
@@ -7803,7 +7960,7 @@
       </p:grpSpPr>
       <p:sp>
         <p:nvSpPr>
-          <p:cNvPr id="2" name="titel-40"/>
+          <p:cNvPr id="2" name="titel-44"/>
           <p:cNvSpPr txBox="1"/>
           <p:nvPr/>
         </p:nvSpPr>
@@ -7839,7 +7996,7 @@
       </p:sp>
       <p:sp>
         <p:nvSpPr>
-          <p:cNvPr id="3" name="list-41"/>
+          <p:cNvPr id="3" name="list-45"/>
           <p:cNvSpPr txBox="1"/>
           <p:nvPr/>
         </p:nvSpPr>
@@ -8023,7 +8180,7 @@
       </p:sp>
       <p:sp>
         <p:nvSpPr>
-          <p:cNvPr id="4" name="list-42"/>
+          <p:cNvPr id="4" name="list-46"/>
           <p:cNvSpPr txBox="1"/>
           <p:nvPr/>
         </p:nvSpPr>
@@ -8207,7 +8364,7 @@
       </p:sp>
       <p:sp>
         <p:nvSpPr>
-          <p:cNvPr id="5" name="text-43"/>
+          <p:cNvPr id="5" name="text-47"/>
           <p:cNvSpPr txBox="1"/>
           <p:nvPr/>
         </p:nvSpPr>
@@ -8313,7 +8470,7 @@
       </p:grpSpPr>
       <p:sp>
         <p:nvSpPr>
-          <p:cNvPr id="2" name="titel-44"/>
+          <p:cNvPr id="2" name="titel-48"/>
           <p:cNvSpPr txBox="1"/>
           <p:nvPr/>
         </p:nvSpPr>
@@ -8349,7 +8506,7 @@
       </p:sp>
       <p:sp>
         <p:nvSpPr>
-          <p:cNvPr id="3" name="quote-45"/>
+          <p:cNvPr id="3" name="quote-49"/>
           <p:cNvSpPr txBox="1"/>
           <p:nvPr/>
         </p:nvSpPr>
@@ -8474,7 +8631,7 @@
       </p:grpSpPr>
       <p:sp>
         <p:nvSpPr>
-          <p:cNvPr id="2" name="titel-46"/>
+          <p:cNvPr id="2" name="titel-50"/>
           <p:cNvSpPr txBox="1"/>
           <p:nvPr/>
         </p:nvSpPr>
@@ -8510,7 +8667,7 @@
       </p:sp>
       <p:sp>
         <p:nvSpPr>
-          <p:cNvPr id="3" name="box-47"/>
+          <p:cNvPr id="3" name="box-51"/>
           <p:cNvSpPr txBox="1"/>
           <p:nvPr/>
         </p:nvSpPr>
@@ -8550,7 +8707,7 @@
       </p:sp>
       <p:sp>
         <p:nvSpPr>
-          <p:cNvPr id="4" name="tile-48"/>
+          <p:cNvPr id="4" name="tile-52"/>
           <p:cNvSpPr txBox="1"/>
           <p:nvPr/>
         </p:nvSpPr>
@@ -8609,7 +8766,7 @@
       </p:sp>
       <p:sp>
         <p:nvSpPr>
-          <p:cNvPr id="5" name="box-49"/>
+          <p:cNvPr id="5" name="box-53"/>
           <p:cNvSpPr txBox="1"/>
           <p:nvPr/>
         </p:nvSpPr>
@@ -8649,7 +8806,7 @@
       </p:sp>
       <p:sp>
         <p:nvSpPr>
-          <p:cNvPr id="6" name="tile-50"/>
+          <p:cNvPr id="6" name="tile-54"/>
           <p:cNvSpPr txBox="1"/>
           <p:nvPr/>
         </p:nvSpPr>
@@ -8708,7 +8865,7 @@
       </p:sp>
       <p:sp>
         <p:nvSpPr>
-          <p:cNvPr id="7" name="box-51"/>
+          <p:cNvPr id="7" name="box-55"/>
           <p:cNvSpPr txBox="1"/>
           <p:nvPr/>
         </p:nvSpPr>
@@ -8748,7 +8905,7 @@
       </p:sp>
       <p:sp>
         <p:nvSpPr>
-          <p:cNvPr id="8" name="tile-52"/>
+          <p:cNvPr id="8" name="tile-56"/>
           <p:cNvSpPr txBox="1"/>
           <p:nvPr/>
         </p:nvSpPr>
@@ -8807,7 +8964,7 @@
       </p:sp>
       <p:sp>
         <p:nvSpPr>
-          <p:cNvPr id="9" name="aufgabe-53"/>
+          <p:cNvPr id="9" name="aufgabe-57"/>
           <p:cNvSpPr txBox="1"/>
           <p:nvPr/>
         </p:nvSpPr>
@@ -8883,7 +9040,7 @@
       </p:sp>
       <p:sp>
         <p:nvSpPr>
-          <p:cNvPr id="10" name="text-54"/>
+          <p:cNvPr id="10" name="text-58"/>
           <p:cNvSpPr txBox="1"/>
           <p:nvPr/>
         </p:nvSpPr>

</xml_diff>